<commit_message>
Update Read the Docs PPT
</commit_message>
<xml_diff>
--- a/Read_The_Docs.pptx
+++ b/Read_The_Docs.pptx
@@ -207,7 +207,7 @@
           <a:p>
             <a:fld id="{9D961D71-DB32-044A-B69C-196275FDCEB4}" type="datetimeFigureOut">
               <a:rPr lang="en-GB" smtClean="0"/>
-              <a:t>05/10/2025</a:t>
+              <a:t>05/04/2026</a:t>
             </a:fld>
             <a:endParaRPr lang="en-GB"/>
           </a:p>
@@ -503,6 +503,93 @@
           </p:nvPr>
         </p:nvSpPr>
         <p:spPr/>
+      </p:sp>
+      <p:sp>
+        <p:nvSpPr>
+          <p:cNvPr id="3" name="Espace réservé des notes 2"/>
+          <p:cNvSpPr>
+            <a:spLocks noGrp="1"/>
+          </p:cNvSpPr>
+          <p:nvPr>
+            <p:ph type="body" idx="1"/>
+          </p:nvPr>
+        </p:nvSpPr>
+        <p:spPr/>
+        <p:txBody>
+          <a:bodyPr/>
+          <a:lstStyle/>
+          <a:p>
+            <a:r>
+              <a:rPr lang="en-GB"/>
+              <a:t>Guidelines</a:t>
+            </a:r>
+          </a:p>
+        </p:txBody>
+      </p:sp>
+      <p:sp>
+        <p:nvSpPr>
+          <p:cNvPr id="4" name="Espace réservé du numéro de diapositive 3"/>
+          <p:cNvSpPr>
+            <a:spLocks noGrp="1"/>
+          </p:cNvSpPr>
+          <p:nvPr>
+            <p:ph type="sldNum" sz="quarter" idx="5"/>
+          </p:nvPr>
+        </p:nvSpPr>
+        <p:spPr/>
+        <p:txBody>
+          <a:bodyPr/>
+          <a:lstStyle/>
+          <a:p>
+            <a:fld id="{B5A0F618-4889-CA4F-A513-BF68A61F17CC}" type="slidenum">
+              <a:rPr lang="en-GB" smtClean="0"/>
+              <a:t>1</a:t>
+            </a:fld>
+            <a:endParaRPr lang="en-GB"/>
+          </a:p>
+        </p:txBody>
+      </p:sp>
+    </p:spTree>
+    <p:extLst>
+      <p:ext uri="{BB962C8B-B14F-4D97-AF65-F5344CB8AC3E}">
+        <p14:creationId xmlns:p14="http://schemas.microsoft.com/office/powerpoint/2010/main" val="2261537336"/>
+      </p:ext>
+    </p:extLst>
+  </p:cSld>
+  <p:clrMapOvr>
+    <a:masterClrMapping/>
+  </p:clrMapOvr>
+</p:notes>
+</file>
+
+<file path=ppt/notesSlides/notesSlide2.xml><?xml version="1.0" encoding="utf-8"?>
+<p:notes xmlns:a="http://schemas.openxmlformats.org/drawingml/2006/main" xmlns:r="http://schemas.openxmlformats.org/officeDocument/2006/relationships" xmlns:p="http://schemas.openxmlformats.org/presentationml/2006/main">
+  <p:cSld>
+    <p:spTree>
+      <p:nvGrpSpPr>
+        <p:cNvPr id="1" name=""/>
+        <p:cNvGrpSpPr/>
+        <p:nvPr/>
+      </p:nvGrpSpPr>
+      <p:grpSpPr>
+        <a:xfrm>
+          <a:off x="0" y="0"/>
+          <a:ext cx="0" cy="0"/>
+          <a:chOff x="0" y="0"/>
+          <a:chExt cx="0" cy="0"/>
+        </a:xfrm>
+      </p:grpSpPr>
+      <p:sp>
+        <p:nvSpPr>
+          <p:cNvPr id="2" name="Espace réservé de l'image des diapositives 1"/>
+          <p:cNvSpPr>
+            <a:spLocks noGrp="1" noRot="1" noChangeAspect="1"/>
+          </p:cNvSpPr>
+          <p:nvPr>
+            <p:ph type="sldImg"/>
+          </p:nvPr>
+        </p:nvSpPr>
+        <p:spPr/>
         <p:txBody>
           <a:bodyPr/>
           <a:lstStyle/>
@@ -758,7 +845,7 @@
           <a:p>
             <a:fld id="{0C2A9868-E8C2-9545-9B20-01B29548202A}" type="datetimeFigureOut">
               <a:rPr lang="en-GB" smtClean="0"/>
-              <a:t>05/10/2025</a:t>
+              <a:t>05/04/2026</a:t>
             </a:fld>
             <a:endParaRPr lang="en-GB" dirty="0"/>
           </a:p>
@@ -966,7 +1053,7 @@
           <a:p>
             <a:fld id="{0C2A9868-E8C2-9545-9B20-01B29548202A}" type="datetimeFigureOut">
               <a:rPr lang="en-GB" smtClean="0"/>
-              <a:t>05/10/2025</a:t>
+              <a:t>05/04/2026</a:t>
             </a:fld>
             <a:endParaRPr lang="en-GB" dirty="0"/>
           </a:p>
@@ -1176,7 +1263,7 @@
           <a:p>
             <a:fld id="{0C2A9868-E8C2-9545-9B20-01B29548202A}" type="datetimeFigureOut">
               <a:rPr lang="en-GB" smtClean="0"/>
-              <a:t>05/10/2025</a:t>
+              <a:t>05/04/2026</a:t>
             </a:fld>
             <a:endParaRPr lang="en-GB" dirty="0"/>
           </a:p>
@@ -1376,7 +1463,7 @@
           <a:p>
             <a:fld id="{0C2A9868-E8C2-9545-9B20-01B29548202A}" type="datetimeFigureOut">
               <a:rPr lang="en-GB" smtClean="0"/>
-              <a:t>05/10/2025</a:t>
+              <a:t>05/04/2026</a:t>
             </a:fld>
             <a:endParaRPr lang="en-GB" dirty="0"/>
           </a:p>
@@ -1652,7 +1739,7 @@
           <a:p>
             <a:fld id="{0C2A9868-E8C2-9545-9B20-01B29548202A}" type="datetimeFigureOut">
               <a:rPr lang="en-GB" smtClean="0"/>
-              <a:t>05/10/2025</a:t>
+              <a:t>05/04/2026</a:t>
             </a:fld>
             <a:endParaRPr lang="en-GB" dirty="0"/>
           </a:p>
@@ -1920,7 +2007,7 @@
           <a:p>
             <a:fld id="{0C2A9868-E8C2-9545-9B20-01B29548202A}" type="datetimeFigureOut">
               <a:rPr lang="en-GB" smtClean="0"/>
-              <a:t>05/10/2025</a:t>
+              <a:t>05/04/2026</a:t>
             </a:fld>
             <a:endParaRPr lang="en-GB" dirty="0"/>
           </a:p>
@@ -2335,7 +2422,7 @@
           <a:p>
             <a:fld id="{0C2A9868-E8C2-9545-9B20-01B29548202A}" type="datetimeFigureOut">
               <a:rPr lang="en-GB" smtClean="0"/>
-              <a:t>05/10/2025</a:t>
+              <a:t>05/04/2026</a:t>
             </a:fld>
             <a:endParaRPr lang="en-GB" dirty="0"/>
           </a:p>
@@ -2477,7 +2564,7 @@
           <a:p>
             <a:fld id="{0C2A9868-E8C2-9545-9B20-01B29548202A}" type="datetimeFigureOut">
               <a:rPr lang="en-GB" smtClean="0"/>
-              <a:t>05/10/2025</a:t>
+              <a:t>05/04/2026</a:t>
             </a:fld>
             <a:endParaRPr lang="en-GB" dirty="0"/>
           </a:p>
@@ -2590,7 +2677,7 @@
           <a:p>
             <a:fld id="{0C2A9868-E8C2-9545-9B20-01B29548202A}" type="datetimeFigureOut">
               <a:rPr lang="en-GB" smtClean="0"/>
-              <a:t>05/10/2025</a:t>
+              <a:t>05/04/2026</a:t>
             </a:fld>
             <a:endParaRPr lang="en-GB" dirty="0"/>
           </a:p>
@@ -2903,7 +2990,7 @@
           <a:p>
             <a:fld id="{0C2A9868-E8C2-9545-9B20-01B29548202A}" type="datetimeFigureOut">
               <a:rPr lang="en-GB" smtClean="0"/>
-              <a:t>05/10/2025</a:t>
+              <a:t>05/04/2026</a:t>
             </a:fld>
             <a:endParaRPr lang="en-GB" dirty="0"/>
           </a:p>
@@ -3192,7 +3279,7 @@
           <a:p>
             <a:fld id="{0C2A9868-E8C2-9545-9B20-01B29548202A}" type="datetimeFigureOut">
               <a:rPr lang="en-GB" smtClean="0"/>
-              <a:t>05/10/2025</a:t>
+              <a:t>05/04/2026</a:t>
             </a:fld>
             <a:endParaRPr lang="en-GB" dirty="0"/>
           </a:p>
@@ -3435,7 +3522,7 @@
           <a:p>
             <a:fld id="{0C2A9868-E8C2-9545-9B20-01B29548202A}" type="datetimeFigureOut">
               <a:rPr lang="en-GB" smtClean="0"/>
-              <a:t>05/10/2025</a:t>
+              <a:t>05/04/2026</a:t>
             </a:fld>
             <a:endParaRPr lang="en-GB" dirty="0"/>
           </a:p>
@@ -3929,7 +4016,7 @@
           <p:nvPr/>
         </p:nvPicPr>
         <p:blipFill>
-          <a:blip r:embed="rId2"/>
+          <a:blip r:embed="rId3"/>
           <a:stretch>
             <a:fillRect/>
           </a:stretch>
@@ -3959,7 +4046,7 @@
           <p:nvPr/>
         </p:nvPicPr>
         <p:blipFill>
-          <a:blip r:embed="rId3"/>
+          <a:blip r:embed="rId4"/>
           <a:stretch>
             <a:fillRect/>
           </a:stretch>

</xml_diff>